<commit_message>
Updated to match Teams
Updated files and file names to match Teams May 22 2026
</commit_message>
<xml_diff>
--- a/training/English (en)/COBT Training Modules [COBT-T] /02. Open Copyright License/02 Open Copyright License - WT Slides.pptx
+++ b/training/English (en)/COBT Training Modules [COBT-T] /02. Open Copyright License/02 Open Copyright License - WT Slides.pptx
@@ -231,7 +231,7 @@
           <a:p>
             <a:fld id="{AC6AA070-92F4-A447-BB88-F5E94FF9CF8B}" type="datetimeFigureOut">
               <a:rPr lang="en-US" smtClean="0"/>
-              <a:t>1/9/23</a:t>
+              <a:t>11/18/25</a:t>
             </a:fld>
             <a:endParaRPr lang="en-US"/>
           </a:p>
@@ -1055,7 +1055,7 @@
           <a:p>
             <a:fld id="{2D176C0A-5C67-429D-B78E-C0F7FE360763}" type="datetimeFigureOut">
               <a:rPr lang="en-US" smtClean="0"/>
-              <a:t>1/9/23</a:t>
+              <a:t>11/18/25</a:t>
             </a:fld>
             <a:endParaRPr lang="en-US"/>
           </a:p>
@@ -7330,7 +7330,13 @@
           <a:bodyPr/>
           <a:lstStyle/>
           <a:p>
-            <a:endParaRPr lang="en-US" dirty="0"/>
+            <a:br>
+              <a:rPr lang="en-US" dirty="0"/>
+            </a:br>
+            <a:r>
+              <a:rPr lang="en-US" dirty="0"/>
+              <a:t>Creative Commons licensing</a:t>
+            </a:r>
           </a:p>
         </p:txBody>
       </p:sp>
@@ -8763,8 +8769,8 @@
         </p:nvSpPr>
         <p:spPr>
           <a:xfrm>
-            <a:off x="1609673" y="3552565"/>
-            <a:ext cx="5924654" cy="830997"/>
+            <a:off x="1169044" y="3552565"/>
+            <a:ext cx="6748040" cy="954107"/>
           </a:xfrm>
           <a:prstGeom prst="rect">
             <a:avLst/>
@@ -8778,12 +8784,12 @@
           <a:lstStyle/>
           <a:p>
             <a:r>
-              <a:rPr lang="en-US" sz="2400" b="1" dirty="0">
+              <a:rPr lang="en-US" sz="2800" b="1" dirty="0">
                 <a:solidFill>
                   <a:schemeClr val="accent1"/>
                 </a:solidFill>
               </a:rPr>
-              <a:t>How is CC BY-SA copyright different from these traditional exclusive rights?</a:t>
+              <a:t>How is CC BY-SA copyright different from traditional exclusive rights?</a:t>
             </a:r>
           </a:p>
         </p:txBody>
@@ -9500,6 +9506,12 @@
 </file>
 
 <file path=customXml/item1.xml><?xml version="1.0" encoding="utf-8"?>
+<p:properties xmlns:p="http://schemas.microsoft.com/office/2006/metadata/properties" xmlns:xsi="http://www.w3.org/2001/XMLSchema-instance" xmlns:pc="http://schemas.microsoft.com/office/infopath/2007/PartnerControls">
+  <documentManagement/>
+</p:properties>
+</file>
+
+<file path=customXml/item2.xml><?xml version="1.0" encoding="utf-8"?>
 <?mso-contentType ?>
 <FormTemplates xmlns="http://schemas.microsoft.com/sharepoint/v3/contenttype/forms">
   <Display>DocumentLibraryForm</Display>
@@ -9508,15 +9520,9 @@
 </FormTemplates>
 </file>
 
-<file path=customXml/item2.xml><?xml version="1.0" encoding="utf-8"?>
-<p:properties xmlns:p="http://schemas.microsoft.com/office/2006/metadata/properties" xmlns:xsi="http://www.w3.org/2001/XMLSchema-instance" xmlns:pc="http://schemas.microsoft.com/office/infopath/2007/PartnerControls">
-  <documentManagement/>
-</p:properties>
-</file>
-
 <file path=customXml/item3.xml><?xml version="1.0" encoding="utf-8"?>
-<ct:contentTypeSchema xmlns:ct="http://schemas.microsoft.com/office/2006/metadata/contentType" xmlns:ma="http://schemas.microsoft.com/office/2006/metadata/properties/metaAttributes" ct:_="" ma:_="" ma:contentTypeName="Document" ma:contentTypeID="0x0101002F017C5ECD5AE84588140775F5D9B6FC" ma:contentTypeVersion="9" ma:contentTypeDescription="Create a new document." ma:contentTypeScope="" ma:versionID="8ee0fe59cacb1f41a9e66ec0fc8b16cd">
-  <xsd:schema xmlns:xsd="http://www.w3.org/2001/XMLSchema" xmlns:xs="http://www.w3.org/2001/XMLSchema" xmlns:p="http://schemas.microsoft.com/office/2006/metadata/properties" xmlns:ns2="fee82e44-1fa4-4144-8309-00fed2bf4198" xmlns:ns3="1a61c928-f5f6-4989-bd5d-cb8872a1b06d" targetNamespace="http://schemas.microsoft.com/office/2006/metadata/properties" ma:root="true" ma:fieldsID="6b8f5e0ab863febec4bdf2d0bf2c5ecf" ns2:_="" ns3:_="">
+<ct:contentTypeSchema xmlns:ct="http://schemas.microsoft.com/office/2006/metadata/contentType" xmlns:ma="http://schemas.microsoft.com/office/2006/metadata/properties/metaAttributes" ct:_="" ma:_="" ma:contentTypeName="Document" ma:contentTypeID="0x0101002F017C5ECD5AE84588140775F5D9B6FC" ma:contentTypeVersion="10" ma:contentTypeDescription="Create a new document." ma:contentTypeScope="" ma:versionID="e03867d33dc1ec3a90248c3910a051a2">
+  <xsd:schema xmlns:xsd="http://www.w3.org/2001/XMLSchema" xmlns:xs="http://www.w3.org/2001/XMLSchema" xmlns:p="http://schemas.microsoft.com/office/2006/metadata/properties" xmlns:ns2="fee82e44-1fa4-4144-8309-00fed2bf4198" xmlns:ns3="1a61c928-f5f6-4989-bd5d-cb8872a1b06d" targetNamespace="http://schemas.microsoft.com/office/2006/metadata/properties" ma:root="true" ma:fieldsID="b5c260609fc8b53aa4745875326c9dd6" ns2:_="" ns3:_="">
     <xsd:import namespace="fee82e44-1fa4-4144-8309-00fed2bf4198"/>
     <xsd:import namespace="1a61c928-f5f6-4989-bd5d-cb8872a1b06d"/>
     <xsd:element name="properties">
@@ -9534,6 +9540,7 @@
                 <xsd:element ref="ns2:MediaServiceObjectDetectorVersions" minOccurs="0"/>
                 <xsd:element ref="ns2:MediaServiceGenerationTime" minOccurs="0"/>
                 <xsd:element ref="ns2:MediaServiceEventHashCode" minOccurs="0"/>
+                <xsd:element ref="ns2:MediaServiceSearchProperties" minOccurs="0"/>
               </xsd:all>
             </xsd:complexType>
           </xsd:element>
@@ -9577,6 +9584,11 @@
     <xsd:element name="MediaServiceEventHashCode" ma:index="16" nillable="true" ma:displayName="MediaServiceEventHashCode" ma:hidden="true" ma:internalName="MediaServiceEventHashCode" ma:readOnly="true">
       <xsd:simpleType>
         <xsd:restriction base="dms:Text"/>
+      </xsd:simpleType>
+    </xsd:element>
+    <xsd:element name="MediaServiceSearchProperties" ma:index="17" nillable="true" ma:displayName="MediaServiceSearchProperties" ma:hidden="true" ma:internalName="MediaServiceSearchProperties" ma:readOnly="true">
+      <xsd:simpleType>
+        <xsd:restriction base="dms:Note"/>
       </xsd:simpleType>
     </xsd:element>
   </xsd:schema>
@@ -9710,14 +9722,6 @@
 </file>
 
 <file path=customXml/itemProps1.xml><?xml version="1.0" encoding="utf-8"?>
-<ds:datastoreItem xmlns:ds="http://schemas.openxmlformats.org/officeDocument/2006/customXml" ds:itemID="{B178770A-F6AC-406B-AF0D-88CBCF36B701}">
-  <ds:schemaRefs>
-    <ds:schemaRef ds:uri="http://schemas.microsoft.com/sharepoint/v3/contenttype/forms"/>
-  </ds:schemaRefs>
-</ds:datastoreItem>
-</file>
-
-<file path=customXml/itemProps2.xml><?xml version="1.0" encoding="utf-8"?>
 <ds:datastoreItem xmlns:ds="http://schemas.openxmlformats.org/officeDocument/2006/customXml" ds:itemID="{DD870300-B03F-45F7-9154-521D8C74684E}">
   <ds:schemaRefs>
     <ds:schemaRef ds:uri="http://purl.org/dc/dcmitype/"/>
@@ -9734,6 +9738,14 @@
 </ds:datastoreItem>
 </file>
 
+<file path=customXml/itemProps2.xml><?xml version="1.0" encoding="utf-8"?>
+<ds:datastoreItem xmlns:ds="http://schemas.openxmlformats.org/officeDocument/2006/customXml" ds:itemID="{B178770A-F6AC-406B-AF0D-88CBCF36B701}">
+  <ds:schemaRefs>
+    <ds:schemaRef ds:uri="http://schemas.microsoft.com/sharepoint/v3/contenttype/forms"/>
+  </ds:schemaRefs>
+</ds:datastoreItem>
+</file>
+
 <file path=customXml/itemProps3.xml><?xml version="1.0" encoding="utf-8"?>
-<ds:datastoreItem xmlns:ds="http://schemas.openxmlformats.org/officeDocument/2006/customXml" ds:itemID="{096B1E01-B96C-4AB5-AE04-354F7CC22AFD}"/>
+<ds:datastoreItem xmlns:ds="http://schemas.openxmlformats.org/officeDocument/2006/customXml" ds:itemID="{3EDD6F70-1D5A-4464-8E64-3D7A53844382}"/>
 </file>
</xml_diff>